<commit_message>
Update Presentation V3 (no video).pptx
</commit_message>
<xml_diff>
--- a/Documents/Presentation V3 (no video).pptx
+++ b/Documents/Presentation V3 (no video).pptx
@@ -182,14 +182,6 @@
 </p:presentation>
 </file>
 
-<file path=ppt/revisionInfo.xml><?xml version="1.0" encoding="utf-8"?>
-<p1510:revInfo xmlns:a="http://schemas.openxmlformats.org/drawingml/2006/main" xmlns:r="http://schemas.openxmlformats.org/officeDocument/2006/relationships" xmlns:p1510="http://schemas.microsoft.com/office/powerpoint/2015/10/main">
-  <p1510:revLst>
-    <p1510:client id="{8E5030DF-0858-4272-8062-504800F360ED}" v="16" dt="2024-05-28T23:11:04.161"/>
-  </p1510:revLst>
-</p1510:revInfo>
-</file>
-
 <file path=ppt/changesInfos/changesInfo1.xml><?xml version="1.0" encoding="utf-8"?>
 <pc:chgInfo xmlns:a="http://schemas.openxmlformats.org/drawingml/2006/main" xmlns:r="http://schemas.openxmlformats.org/officeDocument/2006/relationships" xmlns:ac="http://schemas.microsoft.com/office/drawing/2013/main/command" xmlns:pc="http://schemas.microsoft.com/office/powerpoint/2013/main/command">
   <pc:docChgLst>
@@ -205,94 +197,30 @@
           <pc:docMk/>
           <pc:sldMk cId="59761709" sldId="263"/>
         </pc:sldMkLst>
-        <pc:spChg chg="mod">
-          <ac:chgData name="Gursager Singh Hardeep Singh" userId="150115ac-84f6-40c9-87c8-e36d85a12961" providerId="ADAL" clId="{8E5030DF-0858-4272-8062-504800F360ED}" dt="2024-05-28T23:06:23.460" v="32" actId="26606"/>
-          <ac:spMkLst>
+      </pc:sldChg>
+    </pc:docChg>
+  </pc:docChgLst>
+  <pc:docChgLst>
+    <pc:chgData name="Gursager Singh Hardeep Singh" userId="150115ac-84f6-40c9-87c8-e36d85a12961" providerId="ADAL" clId="{3B01B11D-7FB7-44B1-B92E-1F8C83C13F85}"/>
+    <pc:docChg chg="undo custSel modSld">
+      <pc:chgData name="Gursager Singh Hardeep Singh" userId="150115ac-84f6-40c9-87c8-e36d85a12961" providerId="ADAL" clId="{3B01B11D-7FB7-44B1-B92E-1F8C83C13F85}" dt="2025-03-01T16:04:51.015" v="5" actId="1035"/>
+      <pc:docMkLst>
+        <pc:docMk/>
+      </pc:docMkLst>
+      <pc:sldChg chg="modSp mod">
+        <pc:chgData name="Gursager Singh Hardeep Singh" userId="150115ac-84f6-40c9-87c8-e36d85a12961" providerId="ADAL" clId="{3B01B11D-7FB7-44B1-B92E-1F8C83C13F85}" dt="2025-03-01T16:04:51.015" v="5" actId="1035"/>
+        <pc:sldMkLst>
+          <pc:docMk/>
+          <pc:sldMk cId="2041674452" sldId="272"/>
+        </pc:sldMkLst>
+        <pc:cxnChg chg="mod">
+          <ac:chgData name="Gursager Singh Hardeep Singh" userId="150115ac-84f6-40c9-87c8-e36d85a12961" providerId="ADAL" clId="{3B01B11D-7FB7-44B1-B92E-1F8C83C13F85}" dt="2025-03-01T16:04:51.015" v="5" actId="1035"/>
+          <ac:cxnSpMkLst>
             <pc:docMk/>
-            <pc:sldMk cId="59761709" sldId="263"/>
-            <ac:spMk id="2" creationId="{B588127C-AB9A-9841-0CF7-40176E27A004}"/>
-          </ac:spMkLst>
-        </pc:spChg>
-        <pc:spChg chg="mod">
-          <ac:chgData name="Gursager Singh Hardeep Singh" userId="150115ac-84f6-40c9-87c8-e36d85a12961" providerId="ADAL" clId="{8E5030DF-0858-4272-8062-504800F360ED}" dt="2024-05-28T23:11:55.976" v="62" actId="20577"/>
-          <ac:spMkLst>
-            <pc:docMk/>
-            <pc:sldMk cId="59761709" sldId="263"/>
-            <ac:spMk id="3" creationId="{645391DE-DBB2-FEBF-A33B-4430CBAA6017}"/>
-          </ac:spMkLst>
-        </pc:spChg>
-        <pc:spChg chg="add del mod">
-          <ac:chgData name="Gursager Singh Hardeep Singh" userId="150115ac-84f6-40c9-87c8-e36d85a12961" providerId="ADAL" clId="{8E5030DF-0858-4272-8062-504800F360ED}" dt="2024-05-28T23:06:21.490" v="31"/>
-          <ac:spMkLst>
-            <pc:docMk/>
-            <pc:sldMk cId="59761709" sldId="263"/>
-            <ac:spMk id="4" creationId="{C2C73566-97B3-79EF-5628-C9E5E960CFC3}"/>
-          </ac:spMkLst>
-        </pc:spChg>
-        <pc:spChg chg="mod">
-          <ac:chgData name="Gursager Singh Hardeep Singh" userId="150115ac-84f6-40c9-87c8-e36d85a12961" providerId="ADAL" clId="{8E5030DF-0858-4272-8062-504800F360ED}" dt="2024-05-28T23:06:23.460" v="32" actId="26606"/>
-          <ac:spMkLst>
-            <pc:docMk/>
-            <pc:sldMk cId="59761709" sldId="263"/>
-            <ac:spMk id="5" creationId="{BDEB1135-B5D5-23CB-A5AF-70F12C2DA86E}"/>
-          </ac:spMkLst>
-        </pc:spChg>
-        <pc:spChg chg="mod">
-          <ac:chgData name="Gursager Singh Hardeep Singh" userId="150115ac-84f6-40c9-87c8-e36d85a12961" providerId="ADAL" clId="{8E5030DF-0858-4272-8062-504800F360ED}" dt="2024-05-28T23:06:23.460" v="32" actId="26606"/>
-          <ac:spMkLst>
-            <pc:docMk/>
-            <pc:sldMk cId="59761709" sldId="263"/>
-            <ac:spMk id="6" creationId="{71F3F786-8E77-1BD4-D379-79890E15041B}"/>
-          </ac:spMkLst>
-        </pc:spChg>
-        <pc:spChg chg="mod">
-          <ac:chgData name="Gursager Singh Hardeep Singh" userId="150115ac-84f6-40c9-87c8-e36d85a12961" providerId="ADAL" clId="{8E5030DF-0858-4272-8062-504800F360ED}" dt="2024-05-28T23:06:23.460" v="32" actId="26606"/>
-          <ac:spMkLst>
-            <pc:docMk/>
-            <pc:sldMk cId="59761709" sldId="263"/>
-            <ac:spMk id="7" creationId="{4E5A1AE2-215A-2D01-6099-EA92A823CD50}"/>
-          </ac:spMkLst>
-        </pc:spChg>
-        <pc:spChg chg="add del mod">
-          <ac:chgData name="Gursager Singh Hardeep Singh" userId="150115ac-84f6-40c9-87c8-e36d85a12961" providerId="ADAL" clId="{8E5030DF-0858-4272-8062-504800F360ED}" dt="2024-05-28T23:10:46.025" v="42"/>
-          <ac:spMkLst>
-            <pc:docMk/>
-            <pc:sldMk cId="59761709" sldId="263"/>
-            <ac:spMk id="8" creationId="{943D74D5-6B35-2F98-E181-E551F96871AC}"/>
-          </ac:spMkLst>
-        </pc:spChg>
-        <pc:spChg chg="add">
-          <ac:chgData name="Gursager Singh Hardeep Singh" userId="150115ac-84f6-40c9-87c8-e36d85a12961" providerId="ADAL" clId="{8E5030DF-0858-4272-8062-504800F360ED}" dt="2024-05-28T23:06:23.460" v="32" actId="26606"/>
-          <ac:spMkLst>
-            <pc:docMk/>
-            <pc:sldMk cId="59761709" sldId="263"/>
-            <ac:spMk id="1030" creationId="{C20CE451-818C-E63D-258B-234B6C543D34}"/>
-          </ac:spMkLst>
-        </pc:spChg>
-        <pc:picChg chg="add mod">
-          <ac:chgData name="Gursager Singh Hardeep Singh" userId="150115ac-84f6-40c9-87c8-e36d85a12961" providerId="ADAL" clId="{8E5030DF-0858-4272-8062-504800F360ED}" dt="2024-05-28T23:11:04.160" v="46" actId="14100"/>
-          <ac:picMkLst>
-            <pc:docMk/>
-            <pc:sldMk cId="59761709" sldId="263"/>
-            <ac:picMk id="9" creationId="{61EE4160-3D28-132C-D529-76E7D8C1FF93}"/>
-          </ac:picMkLst>
-        </pc:picChg>
-        <pc:picChg chg="add del mod ord">
-          <ac:chgData name="Gursager Singh Hardeep Singh" userId="150115ac-84f6-40c9-87c8-e36d85a12961" providerId="ADAL" clId="{8E5030DF-0858-4272-8062-504800F360ED}" dt="2024-05-28T23:07:09.899" v="41" actId="478"/>
-          <ac:picMkLst>
-            <pc:docMk/>
-            <pc:sldMk cId="59761709" sldId="263"/>
-            <ac:picMk id="1025" creationId="{BE6CCAC5-DBA4-FFAB-A118-F2AA9EF0DF4E}"/>
-          </ac:picMkLst>
-        </pc:picChg>
-        <pc:picChg chg="del">
-          <ac:chgData name="Gursager Singh Hardeep Singh" userId="150115ac-84f6-40c9-87c8-e36d85a12961" providerId="ADAL" clId="{8E5030DF-0858-4272-8062-504800F360ED}" dt="2024-05-28T23:06:19.701" v="30" actId="478"/>
-          <ac:picMkLst>
-            <pc:docMk/>
-            <pc:sldMk cId="59761709" sldId="263"/>
-            <ac:picMk id="1026" creationId="{26F4DA73-C4BE-4107-B962-39CB26159341}"/>
-          </ac:picMkLst>
-        </pc:picChg>
+            <pc:sldMk cId="2041674452" sldId="272"/>
+            <ac:cxnSpMk id="22" creationId="{BB9ED62C-66A4-3D6F-17CD-3DEEDDC31D50}"/>
+          </ac:cxnSpMkLst>
+        </pc:cxnChg>
       </pc:sldChg>
     </pc:docChg>
   </pc:docChgLst>
@@ -1269,7 +1197,7 @@
           <a:p>
             <a:fld id="{11A2C24C-7D4B-4A9E-B25A-DCBA4500F8D2}" type="datetimeFigureOut">
               <a:rPr lang="en-GB" smtClean="0"/>
-              <a:t>29/05/2024</a:t>
+              <a:t>01/03/2025</a:t>
             </a:fld>
             <a:endParaRPr lang="en-GB"/>
           </a:p>
@@ -1683,7 +1611,7 @@
               <a:defRPr/>
             </a:pPr>
             <a:r>
-              <a:rPr lang="en-GB"/>
+              <a:rPr lang="en-GB" dirty="0"/>
               <a:t>The GPIO pins on the Pi are designed to handle a maximum of 3.3 V. Exceeding this voltage can damage the Pi. This is a problem since the ultrasonic sensor operates at 5 V so, when the sensor sends an echo signal (indicating that it has detected an object) to the pi, the voltage level of this signal will be about 5 V. So, a potential divider is used to lower the echo signal voltage.</a:t>
             </a:r>
           </a:p>
@@ -1705,7 +1633,7 @@
               <a:tabLst/>
               <a:defRPr/>
             </a:pPr>
-            <a:endParaRPr lang="en-GB"/>
+            <a:endParaRPr lang="en-GB" dirty="0"/>
           </a:p>
           <a:p>
             <a:pPr marL="0" marR="0" lvl="0" indent="0" algn="l" defTabSz="914400" rtl="0" eaLnBrk="1" fontAlgn="auto" latinLnBrk="0" hangingPunct="1">
@@ -1726,12 +1654,12 @@
               <a:defRPr/>
             </a:pPr>
             <a:r>
-              <a:rPr lang="en-GB"/>
+              <a:rPr lang="en-GB" dirty="0"/>
               <a:t>DO NOT READ: the echo signal is a series of HIGH &amp; LOW (3.3V or 0 V) signals, so don’t have to save integrity of wave or anything like that</a:t>
             </a:r>
           </a:p>
           <a:p>
-            <a:endParaRPr lang="en-GB"/>
+            <a:endParaRPr lang="en-GB" dirty="0"/>
           </a:p>
         </p:txBody>
       </p:sp>
@@ -3481,7 +3409,7 @@
           <a:p>
             <a:fld id="{77CA0979-F579-4E9B-A675-1F5ABBFF00DB}" type="datetime1">
               <a:rPr lang="en-US" smtClean="0"/>
-              <a:t>5/29/2024</a:t>
+              <a:t>3/1/2025</a:t>
             </a:fld>
             <a:endParaRPr lang="en-US"/>
           </a:p>
@@ -3689,7 +3617,7 @@
           <a:p>
             <a:fld id="{F7E76D0F-5A12-4D0A-80B0-1A6122B61E7B}" type="datetime1">
               <a:rPr lang="en-US" smtClean="0"/>
-              <a:t>5/29/2024</a:t>
+              <a:t>3/1/2025</a:t>
             </a:fld>
             <a:endParaRPr lang="en-US"/>
           </a:p>
@@ -3897,7 +3825,7 @@
           <a:p>
             <a:fld id="{8B9E8C84-89CA-44AB-B0BE-5C91BAF75478}" type="datetime1">
               <a:rPr lang="en-US" smtClean="0"/>
-              <a:t>5/29/2024</a:t>
+              <a:t>3/1/2025</a:t>
             </a:fld>
             <a:endParaRPr lang="en-US"/>
           </a:p>
@@ -4095,7 +4023,7 @@
           <a:p>
             <a:fld id="{73E7156E-175E-4DBA-9D21-B772C320F342}" type="datetime1">
               <a:rPr lang="en-US" smtClean="0"/>
-              <a:t>5/29/2024</a:t>
+              <a:t>3/1/2025</a:t>
             </a:fld>
             <a:endParaRPr lang="en-US"/>
           </a:p>
@@ -4372,7 +4300,7 @@
           <a:p>
             <a:fld id="{04895F6E-3D02-4292-95D1-C62B3126321B}" type="datetime1">
               <a:rPr lang="en-US" smtClean="0"/>
-              <a:t>5/29/2024</a:t>
+              <a:t>3/1/2025</a:t>
             </a:fld>
             <a:endParaRPr lang="en-US"/>
           </a:p>
@@ -4642,7 +4570,7 @@
           <a:p>
             <a:fld id="{EDCB5ACB-D10C-44A8-9570-124370F4CB38}" type="datetime1">
               <a:rPr lang="en-US" smtClean="0"/>
-              <a:t>5/29/2024</a:t>
+              <a:t>3/1/2025</a:t>
             </a:fld>
             <a:endParaRPr lang="en-US"/>
           </a:p>
@@ -5064,7 +4992,7 @@
           <a:p>
             <a:fld id="{AB8D84F4-0E7A-4BDE-98C6-AE68FB974645}" type="datetime1">
               <a:rPr lang="en-US" smtClean="0"/>
-              <a:t>5/29/2024</a:t>
+              <a:t>3/1/2025</a:t>
             </a:fld>
             <a:endParaRPr lang="en-US"/>
           </a:p>
@@ -5205,7 +5133,7 @@
           <a:p>
             <a:fld id="{CBEFF1D8-9801-4C4B-92F3-66C9A863BD74}" type="datetime1">
               <a:rPr lang="en-US" smtClean="0"/>
-              <a:t>5/29/2024</a:t>
+              <a:t>3/1/2025</a:t>
             </a:fld>
             <a:endParaRPr lang="en-US"/>
           </a:p>
@@ -5318,7 +5246,7 @@
           <a:p>
             <a:fld id="{961FE8FD-B23E-4E1A-83EF-0847EBEA0105}" type="datetime1">
               <a:rPr lang="en-US" smtClean="0"/>
-              <a:t>5/29/2024</a:t>
+              <a:t>3/1/2025</a:t>
             </a:fld>
             <a:endParaRPr lang="en-US"/>
           </a:p>
@@ -5635,7 +5563,7 @@
           <a:p>
             <a:fld id="{8DDF891E-A7C2-465C-AD39-8EDCB0F58E3C}" type="datetime1">
               <a:rPr lang="en-US" smtClean="0"/>
-              <a:t>5/29/2024</a:t>
+              <a:t>3/1/2025</a:t>
             </a:fld>
             <a:endParaRPr lang="en-US"/>
           </a:p>
@@ -5928,7 +5856,7 @@
           <a:p>
             <a:fld id="{F39F93E5-AFB6-485C-8E3C-32F92A07875F}" type="datetime1">
               <a:rPr lang="en-US" smtClean="0"/>
-              <a:t>5/29/2024</a:t>
+              <a:t>3/1/2025</a:t>
             </a:fld>
             <a:endParaRPr lang="en-US"/>
           </a:p>
@@ -6167,7 +6095,7 @@
           <a:p>
             <a:fld id="{3A332BE1-279E-4118-9FE3-7952B079A510}" type="datetime1">
               <a:rPr lang="en-US" smtClean="0"/>
-              <a:t>5/29/2024</a:t>
+              <a:t>3/1/2025</a:t>
             </a:fld>
             <a:endParaRPr lang="en-US"/>
           </a:p>
@@ -7606,7 +7534,7 @@
                   <a:spcPts val="600"/>
                 </a:spcAft>
               </a:pPr>
-              <a:t>5/29/2024</a:t>
+              <a:t>3/1/2025</a:t>
             </a:fld>
             <a:endParaRPr lang="en-US"/>
           </a:p>
@@ -8218,7 +8146,7 @@
                   <a:spcPts val="600"/>
                 </a:spcAft>
               </a:pPr>
-              <a:t>5/29/2024</a:t>
+              <a:t>3/1/2025</a:t>
             </a:fld>
             <a:endParaRPr lang="en-US"/>
           </a:p>
@@ -8548,7 +8476,7 @@
                   <a:spcPts val="600"/>
                 </a:spcAft>
               </a:pPr>
-              <a:t>5/29/2024</a:t>
+              <a:t>3/1/2025</a:t>
             </a:fld>
             <a:endParaRPr lang="en-US"/>
           </a:p>
@@ -8870,7 +8798,7 @@
                   <a:spcPts val="600"/>
                 </a:spcAft>
               </a:pPr>
-              <a:t>5/29/2024</a:t>
+              <a:t>3/1/2025</a:t>
             </a:fld>
             <a:endParaRPr lang="en-US"/>
           </a:p>
@@ -9085,7 +9013,7 @@
           <a:p>
             <a:fld id="{73E7156E-175E-4DBA-9D21-B772C320F342}" type="datetime1">
               <a:rPr lang="en-US" smtClean="0"/>
-              <a:t>5/29/2024</a:t>
+              <a:t>3/1/2025</a:t>
             </a:fld>
             <a:endParaRPr lang="en-US"/>
           </a:p>
@@ -9790,7 +9718,7 @@
           <a:p>
             <a:fld id="{73E7156E-175E-4DBA-9D21-B772C320F342}" type="datetime1">
               <a:rPr lang="en-US" smtClean="0"/>
-              <a:t>5/29/2024</a:t>
+              <a:t>3/1/2025</a:t>
             </a:fld>
             <a:endParaRPr lang="en-US"/>
           </a:p>
@@ -10270,7 +10198,7 @@
           <a:p>
             <a:fld id="{77CA0979-F579-4E9B-A675-1F5ABBFF00DB}" type="datetime1">
               <a:rPr lang="en-US" smtClean="0"/>
-              <a:t>5/29/2024</a:t>
+              <a:t>3/1/2025</a:t>
             </a:fld>
             <a:endParaRPr lang="en-US"/>
           </a:p>
@@ -10612,7 +10540,7 @@
                   <a:spcPts val="600"/>
                 </a:spcAft>
               </a:pPr>
-              <a:t>5/29/2024</a:t>
+              <a:t>3/1/2025</a:t>
             </a:fld>
             <a:endParaRPr lang="en-US"/>
           </a:p>
@@ -10841,7 +10769,7 @@
           <a:p>
             <a:fld id="{77CA0979-F579-4E9B-A675-1F5ABBFF00DB}" type="datetime1">
               <a:rPr lang="en-US" smtClean="0"/>
-              <a:t>5/29/2024</a:t>
+              <a:t>3/1/2025</a:t>
             </a:fld>
             <a:endParaRPr lang="en-US"/>
           </a:p>
@@ -11043,7 +10971,7 @@
           <a:p>
             <a:fld id="{77CA0979-F579-4E9B-A675-1F5ABBFF00DB}" type="datetime1">
               <a:rPr lang="en-US" smtClean="0"/>
-              <a:t>5/29/2024</a:t>
+              <a:t>3/1/2025</a:t>
             </a:fld>
             <a:endParaRPr lang="en-US"/>
           </a:p>
@@ -11192,7 +11120,7 @@
           <a:p>
             <a:fld id="{77CA0979-F579-4E9B-A675-1F5ABBFF00DB}" type="datetime1">
               <a:rPr lang="en-US" smtClean="0"/>
-              <a:t>5/29/2024</a:t>
+              <a:t>3/1/2025</a:t>
             </a:fld>
             <a:endParaRPr lang="en-US"/>
           </a:p>
@@ -11375,7 +11303,7 @@
           <a:p>
             <a:fld id="{73E7156E-175E-4DBA-9D21-B772C320F342}" type="datetime1">
               <a:rPr lang="en-US" smtClean="0"/>
-              <a:t>5/29/2024</a:t>
+              <a:t>3/1/2025</a:t>
             </a:fld>
             <a:endParaRPr lang="en-US"/>
           </a:p>
@@ -14059,7 +13987,7 @@
           <a:p>
             <a:fld id="{73E7156E-175E-4DBA-9D21-B772C320F342}" type="datetime1">
               <a:rPr lang="en-US" smtClean="0"/>
-              <a:t>5/29/2024</a:t>
+              <a:t>3/1/2025</a:t>
             </a:fld>
             <a:endParaRPr lang="en-US"/>
           </a:p>
@@ -14951,7 +14879,7 @@
                   <a:spcPts val="600"/>
                 </a:spcAft>
               </a:pPr>
-              <a:t>5/29/2024</a:t>
+              <a:t>3/1/2025</a:t>
             </a:fld>
             <a:endParaRPr lang="en-US"/>
           </a:p>
@@ -15893,7 +15821,7 @@
                   <a:spcPts val="600"/>
                 </a:spcAft>
               </a:pPr>
-              <a:t>5/29/2024</a:t>
+              <a:t>3/1/2025</a:t>
             </a:fld>
             <a:endParaRPr lang="en-US"/>
           </a:p>
@@ -16222,7 +16150,7 @@
                   <a:spcPts val="600"/>
                 </a:spcAft>
               </a:pPr>
-              <a:t>5/29/2024</a:t>
+              <a:t>3/1/2025</a:t>
             </a:fld>
             <a:endParaRPr lang="en-US"/>
           </a:p>
@@ -16595,7 +16523,7 @@
         </p:nvCxnSpPr>
         <p:spPr>
           <a:xfrm>
-            <a:off x="8349432" y="3276600"/>
+            <a:off x="8349432" y="3261360"/>
             <a:ext cx="93509" cy="559663"/>
           </a:xfrm>
           <a:prstGeom prst="straightConnector1">
@@ -17833,7 +17761,7 @@
                   <a:spcPts val="600"/>
                 </a:spcAft>
               </a:pPr>
-              <a:t>5/29/2024</a:t>
+              <a:t>3/1/2025</a:t>
             </a:fld>
             <a:endParaRPr lang="en-US"/>
           </a:p>
@@ -19421,15 +19349,6 @@
 </file>
 
 <file path=customXml/item1.xml><?xml version="1.0" encoding="utf-8"?>
-<?mso-contentType ?>
-<FormTemplates xmlns="http://schemas.microsoft.com/sharepoint/v3/contenttype/forms">
-  <Display>DocumentLibraryForm</Display>
-  <Edit>DocumentLibraryForm</Edit>
-  <New>DocumentLibraryForm</New>
-</FormTemplates>
-</file>
-
-<file path=customXml/item2.xml><?xml version="1.0" encoding="utf-8"?>
 <ct:contentTypeSchema xmlns:ct="http://schemas.microsoft.com/office/2006/metadata/contentType" xmlns:ma="http://schemas.microsoft.com/office/2006/metadata/properties/metaAttributes" ct:_="" ma:_="" ma:contentTypeName="Document" ma:contentTypeID="0x010100EA9E159B2A2BED4CBF44216BED96E174" ma:contentTypeVersion="16" ma:contentTypeDescription="Create a new document." ma:contentTypeScope="" ma:versionID="79b0dccea6271240274b92965c7ab17c">
   <xsd:schema xmlns:xsd="http://www.w3.org/2001/XMLSchema" xmlns:xs="http://www.w3.org/2001/XMLSchema" xmlns:p="http://schemas.microsoft.com/office/2006/metadata/properties" xmlns:ns2="d68fd8d5-b080-4ed3-a7e8-9e90a601cae7" xmlns:ns3="b6ad5b93-7bdd-4c29-96d2-06029b8580cc" targetNamespace="http://schemas.microsoft.com/office/2006/metadata/properties" ma:root="true" ma:fieldsID="95c5b61a6d66c108de0b15495e534766" ns2:_="" ns3:_="">
     <xsd:import namespace="d68fd8d5-b080-4ed3-a7e8-9e90a601cae7"/>
@@ -19672,15 +19591,16 @@
 </ct:contentTypeSchema>
 </file>
 
-<file path=customXml/itemProps1.xml><?xml version="1.0" encoding="utf-8"?>
-<ds:datastoreItem xmlns:ds="http://schemas.openxmlformats.org/officeDocument/2006/customXml" ds:itemID="{028D461B-47FF-4ED6-AAB1-753EA2F39D95}">
-  <ds:schemaRefs>
-    <ds:schemaRef ds:uri="http://schemas.microsoft.com/sharepoint/v3/contenttype/forms"/>
-  </ds:schemaRefs>
-</ds:datastoreItem>
+<file path=customXml/item2.xml><?xml version="1.0" encoding="utf-8"?>
+<?mso-contentType ?>
+<FormTemplates xmlns="http://schemas.microsoft.com/sharepoint/v3/contenttype/forms">
+  <Display>DocumentLibraryForm</Display>
+  <Edit>DocumentLibraryForm</Edit>
+  <New>DocumentLibraryForm</New>
+</FormTemplates>
 </file>
 
-<file path=customXml/itemProps2.xml><?xml version="1.0" encoding="utf-8"?>
+<file path=customXml/itemProps1.xml><?xml version="1.0" encoding="utf-8"?>
 <ds:datastoreItem xmlns:ds="http://schemas.openxmlformats.org/officeDocument/2006/customXml" ds:itemID="{C8DDF414-3432-46A8-ABB9-279140AB8563}">
   <ds:schemaRefs>
     <ds:schemaRef ds:uri="b6ad5b93-7bdd-4c29-96d2-06029b8580cc"/>
@@ -19698,4 +19618,12 @@
     <ds:schemaRef ds:uri="http://www.w3.org/2001/XMLSchema"/>
   </ds:schemaRefs>
 </ds:datastoreItem>
+</file>
+
+<file path=customXml/itemProps2.xml><?xml version="1.0" encoding="utf-8"?>
+<ds:datastoreItem xmlns:ds="http://schemas.openxmlformats.org/officeDocument/2006/customXml" ds:itemID="{028D461B-47FF-4ED6-AAB1-753EA2F39D95}">
+  <ds:schemaRefs>
+    <ds:schemaRef ds:uri="http://schemas.microsoft.com/sharepoint/v3/contenttype/forms"/>
+  </ds:schemaRefs>
+</ds:datastoreItem>
 </file>
</xml_diff>